<commit_message>
P4: compiled kernels for the six time-domain loops, tolerance provenance, v0.9.4 count fix (#60)
Every engine's per-cycle loop and every block's per-cycle arithmetic is now
a module-level kernel under core.jit.kernel: numba compiles it when the
[fast] extra is installed, the identical Python runs otherwise, and
PLLSIM_JIT=0 forces the interpreted path.  10-50x on the loops, verified
bit-identical across all 18 presets by tests/test_kernels.py.

Also: about forty-five bare test tolerances now carry their measurement or
statistic, and the v0.9.4 documented test count (944/869) is corrected to
the run's actual 883+75=958 with a correction note in the release notes.

Details and pitfalls: cairn/compiled-kernels.md

Co-Authored-By: Claude Opus 5 <noreply@anthropic.com>
Claude-Session: https://claude.ai/code/session_01E4u5MwBxcutcpDK8tWBdTz
</commit_message>
<xml_diff>
--- a/docs/reports/pllsim-项目总结-v0.9.4.pptx
+++ b/docs/reports/pllsim-项目总结-v0.9.4.pptx
@@ -1708,7 +1708,7 @@
                 <a:ea typeface="Microsoft YaHei" pitchFamily="34" charset="-122"/>
                 <a:cs typeface="Microsoft YaHei" pitchFamily="34" charset="-120"/>
               </a:rPr>
-              <a:t>v0.9.4    ·    6 种架构    ·    958 项自动化测试</a:t>
+              <a:t>v0.9.4    ·    6 种架构    ·    962 项自动化测试</a:t>
             </a:r>
             <a:endParaRPr lang="en-US" sz="1400" dirty="0"/>
           </a:p>
@@ -2737,7 +2737,7 @@
                 <a:ea typeface="Microsoft YaHei" pitchFamily="34" charset="-122"/>
                 <a:cs typeface="Microsoft YaHei" pitchFamily="34" charset="-120"/>
               </a:rPr>
-              <a:t>958</a:t>
+              <a:t>962</a:t>
             </a:r>
             <a:endParaRPr lang="en-US" sz="3400" dirty="0"/>
           </a:p>
@@ -8051,7 +8051,7 @@
                 <a:ea typeface="Microsoft YaHei" pitchFamily="34" charset="-122"/>
                 <a:cs typeface="Microsoft YaHei" pitchFamily="34" charset="-120"/>
               </a:rPr>
-              <a:t>958 项自动化测试，每次代码提交在两个 Python 版本上全量运行</a:t>
+              <a:t>962 项自动化测试，每次代码提交在两个 Python 版本上全量运行</a:t>
             </a:r>
             <a:endParaRPr lang="en-US" sz="1400" dirty="0"/>
           </a:p>
@@ -8754,7 +8754,7 @@
                 <a:ea typeface="Microsoft YaHei" pitchFamily="34" charset="-122"/>
                 <a:cs typeface="Microsoft YaHei" pitchFamily="34" charset="-120"/>
               </a:rPr>
-              <a:t>14 个版本全部带发布说明：每一个变动的数字都写明「哪个数变了、为什么」，不悄悄改基准。</a:t>
+              <a:t>16 个版本全部带发布说明：每一个变动的数字都写明「哪个数变了、为什么」，不悄悄改基准。</a:t>
             </a:r>
             <a:endParaRPr lang="en-US" sz="1450" dirty="0"/>
           </a:p>

</xml_diff>